<commit_message>
Add interactive visualizations and enhance analysis details in artigo.tex; update presentation slides
</commit_message>
<xml_diff>
--- a/Seminario_GrafosMetroSP.pptx
+++ b/Seminario_GrafosMetroSP.pptx
@@ -16,9 +16,10 @@
     <p:sldId id="264" r:id="rId10"/>
     <p:sldId id="265" r:id="rId11"/>
     <p:sldId id="266" r:id="rId12"/>
+    <p:sldId id="267" r:id="rId13"/>
   </p:sldIdLst>
   <p:notesMasterIdLst>
-    <p:notesMasterId r:id="rId13"/>
+    <p:notesMasterId r:id="rId14"/>
   </p:notesMasterIdLst>
   <p:sldSz cx="12192000" cy="6858000"/>
   <p:notesSz cx="6858000" cy="12192000"/>
@@ -688,7 +689,7 @@
           <a:p>
             <a:r>
               <a:rPr lang="en-US" dirty="0"/>
-              <a:t/>
+              <a:t>Separação clara de responsabilidades técnicas: NetworkX calcula todas as métricas reportadas no artigo (centralidade, eficiência, comunidades, small-world, robustez), e Three.js/WebGL constrói a camada de visualização interativa no navegador. Tudo versionado e disponível online.</a:t>
             </a:r>
             <a:endParaRPr lang="en-US" dirty="0"/>
           </a:p>
@@ -712,6 +713,94 @@
             <a:fld id="{F7021451-1387-4CA6-816F-3879F97B5CBC}" type="slidenum">
               <a:rPr lang="en-US"/>
               <a:t>11</a:t>
+            </a:fld>
+            <a:endParaRPr lang="en-US"/>
+          </a:p>
+        </p:txBody>
+      </p:sp>
+    </p:spTree>
+    <p:extLst>
+      <p:ext uri="{BB962C8B-B14F-4D97-AF65-F5344CB8AC3E}">
+        <p14:creationId xmlns:p14="http://schemas.microsoft.com/office/powerpoint/2010/main" val="1024086991"/>
+      </p:ext>
+    </p:extLst>
+  </p:cSld>
+  <p:clrMapOvr>
+    <a:masterClrMapping/>
+  </p:clrMapOvr>
+</p:notes>
+</file>
+
+<file path=ppt/notesSlides/notesSlide12.xml><?xml version="1.0" encoding="utf-8"?>
+<p:notes xmlns:a="http://schemas.openxmlformats.org/drawingml/2006/main" xmlns:r="http://schemas.openxmlformats.org/officeDocument/2006/relationships" xmlns:p="http://schemas.openxmlformats.org/presentationml/2006/main">
+  <p:cSld>
+    <p:spTree>
+      <p:nvGrpSpPr>
+        <p:cNvPr id="1" name=""/>
+        <p:cNvGrpSpPr/>
+        <p:nvPr/>
+      </p:nvGrpSpPr>
+      <p:grpSpPr>
+        <a:xfrm>
+          <a:off x="0" y="0"/>
+          <a:ext cx="0" cy="0"/>
+          <a:chOff x="0" y="0"/>
+          <a:chExt cx="0" cy="0"/>
+        </a:xfrm>
+      </p:grpSpPr>
+      <p:sp>
+        <p:nvSpPr>
+          <p:cNvPr id="2" name="Slide Image Placeholder 1"/>
+          <p:cNvSpPr>
+            <a:spLocks noGrp="1" noRot="1" noChangeAspect="1"/>
+          </p:cNvSpPr>
+          <p:nvPr>
+            <p:ph type="sldImg"/>
+          </p:nvPr>
+        </p:nvSpPr>
+        <p:spPr/>
+      </p:sp>
+      <p:sp>
+        <p:nvSpPr>
+          <p:cNvPr id="3" name="Notes Placeholder 2"/>
+          <p:cNvSpPr>
+            <a:spLocks noGrp="1"/>
+          </p:cNvSpPr>
+          <p:nvPr>
+            <p:ph type="body" idx="1"/>
+          </p:nvPr>
+        </p:nvSpPr>
+        <p:spPr/>
+        <p:txBody>
+          <a:bodyPr/>
+          <a:lstStyle/>
+          <a:p>
+            <a:r>
+              <a:rPr lang="en-US" dirty="0"/>
+              <a:t/>
+            </a:r>
+            <a:endParaRPr lang="en-US" dirty="0"/>
+          </a:p>
+        </p:txBody>
+      </p:sp>
+      <p:sp>
+        <p:nvSpPr>
+          <p:cNvPr id="4" name="Slide Number Placeholder 3"/>
+          <p:cNvSpPr>
+            <a:spLocks noGrp="1"/>
+          </p:cNvSpPr>
+          <p:nvPr>
+            <p:ph type="sldNum" sz="quarter" idx="10"/>
+          </p:nvPr>
+        </p:nvSpPr>
+        <p:spPr/>
+        <p:txBody>
+          <a:bodyPr/>
+          <a:lstStyle/>
+          <a:p>
+            <a:fld id="{F7021451-1387-4CA6-816F-3879F97B5CBC}" type="slidenum">
+              <a:rPr lang="en-US"/>
+              <a:t>12</a:t>
             </a:fld>
             <a:endParaRPr lang="en-US"/>
           </a:p>
@@ -2964,6 +3053,664 @@
           <a:chExt cx="0" cy="0"/>
         </a:xfrm>
       </p:grpSpPr>
+      <p:sp>
+        <p:nvSpPr>
+          <p:cNvPr id="2" name="Text 0"/>
+          <p:cNvSpPr/>
+          <p:nvPr/>
+        </p:nvSpPr>
+        <p:spPr>
+          <a:xfrm>
+            <a:off x="548640" y="384048"/>
+            <a:ext cx="8229600" cy="274320"/>
+          </a:xfrm>
+          <a:prstGeom prst="rect">
+            <a:avLst/>
+          </a:prstGeom>
+          <a:noFill/>
+          <a:ln/>
+        </p:spPr>
+        <p:txBody>
+          <a:bodyPr wrap="square" rtlCol="0" anchor="ctr"/>
+          <a:lstStyle/>
+          <a:p>
+            <a:pPr indent="0" marL="0">
+              <a:buNone/>
+            </a:pPr>
+            <a:r>
+              <a:rPr lang="en-US" sz="1200" b="1" spc="300" kern="0" dirty="0">
+                <a:solidFill>
+                  <a:srgbClr val="35D0D6"/>
+                </a:solidFill>
+                <a:latin typeface="Calibri" pitchFamily="34" charset="0"/>
+                <a:ea typeface="Calibri" pitchFamily="34" charset="-122"/>
+                <a:cs typeface="Calibri" pitchFamily="34" charset="-120"/>
+              </a:rPr>
+              <a:t>IMPLEMENTAÇÃO</a:t>
+            </a:r>
+            <a:endParaRPr lang="en-US" sz="1200" dirty="0"/>
+          </a:p>
+        </p:txBody>
+      </p:sp>
+      <p:sp>
+        <p:nvSpPr>
+          <p:cNvPr id="3" name="Text 1"/>
+          <p:cNvSpPr/>
+          <p:nvPr/>
+        </p:nvSpPr>
+        <p:spPr>
+          <a:xfrm>
+            <a:off x="548640" y="658368"/>
+            <a:ext cx="11064240" cy="822960"/>
+          </a:xfrm>
+          <a:prstGeom prst="rect">
+            <a:avLst/>
+          </a:prstGeom>
+          <a:noFill/>
+          <a:ln/>
+        </p:spPr>
+        <p:txBody>
+          <a:bodyPr wrap="square" rtlCol="0" anchor="ctr"/>
+          <a:lstStyle/>
+          <a:p>
+            <a:pPr indent="0" marL="0">
+              <a:buNone/>
+            </a:pPr>
+            <a:r>
+              <a:rPr lang="en-US" sz="3200" b="1" dirty="0">
+                <a:solidFill>
+                  <a:srgbClr val="FFFFFF"/>
+                </a:solidFill>
+                <a:latin typeface="Calibri" pitchFamily="34" charset="0"/>
+                <a:ea typeface="Calibri" pitchFamily="34" charset="-122"/>
+                <a:cs typeface="Calibri" pitchFamily="34" charset="-120"/>
+              </a:rPr>
+              <a:t>Como construímos — análise e visualização</a:t>
+            </a:r>
+            <a:endParaRPr lang="en-US" sz="3200" dirty="0"/>
+          </a:p>
+        </p:txBody>
+      </p:sp>
+      <p:sp>
+        <p:nvSpPr>
+          <p:cNvPr id="4" name="Shape 2"/>
+          <p:cNvSpPr/>
+          <p:nvPr/>
+        </p:nvSpPr>
+        <p:spPr>
+          <a:xfrm>
+            <a:off x="548640" y="1645920"/>
+            <a:ext cx="5486400" cy="3794760"/>
+          </a:xfrm>
+          <a:prstGeom prst="roundRect">
+            <a:avLst>
+              <a:gd name="adj" fmla="val 2892"/>
+            </a:avLst>
+          </a:prstGeom>
+          <a:solidFill>
+            <a:srgbClr val="141B2E"/>
+          </a:solidFill>
+          <a:ln w="12700">
+            <a:solidFill>
+              <a:srgbClr val="2A3550"/>
+            </a:solidFill>
+            <a:prstDash val="solid"/>
+          </a:ln>
+        </p:spPr>
+      </p:sp>
+      <p:sp>
+        <p:nvSpPr>
+          <p:cNvPr id="5" name="Text 3"/>
+          <p:cNvSpPr/>
+          <p:nvPr/>
+        </p:nvSpPr>
+        <p:spPr>
+          <a:xfrm>
+            <a:off x="777240" y="1828800"/>
+            <a:ext cx="5029200" cy="365760"/>
+          </a:xfrm>
+          <a:prstGeom prst="rect">
+            <a:avLst/>
+          </a:prstGeom>
+          <a:noFill/>
+          <a:ln/>
+        </p:spPr>
+        <p:txBody>
+          <a:bodyPr wrap="square" rtlCol="0" anchor="ctr"/>
+          <a:lstStyle/>
+          <a:p>
+            <a:pPr indent="0" marL="0">
+              <a:buNone/>
+            </a:pPr>
+            <a:r>
+              <a:rPr lang="en-US" sz="1600" b="1" dirty="0">
+                <a:solidFill>
+                  <a:srgbClr val="35D0D6"/>
+                </a:solidFill>
+                <a:latin typeface="Calibri" pitchFamily="34" charset="0"/>
+                <a:ea typeface="Calibri" pitchFamily="34" charset="-122"/>
+                <a:cs typeface="Calibri" pitchFamily="34" charset="-120"/>
+              </a:rPr>
+              <a:t>Análise · Python + NetworkX</a:t>
+            </a:r>
+            <a:endParaRPr lang="en-US" sz="1600" dirty="0"/>
+          </a:p>
+        </p:txBody>
+      </p:sp>
+      <p:sp>
+        <p:nvSpPr>
+          <p:cNvPr id="6" name="Text 4"/>
+          <p:cNvSpPr/>
+          <p:nvPr/>
+        </p:nvSpPr>
+        <p:spPr>
+          <a:xfrm>
+            <a:off x="777240" y="2267712"/>
+            <a:ext cx="5029200" cy="548640"/>
+          </a:xfrm>
+          <a:prstGeom prst="rect">
+            <a:avLst/>
+          </a:prstGeom>
+          <a:noFill/>
+          <a:ln/>
+        </p:spPr>
+        <p:txBody>
+          <a:bodyPr wrap="square" rtlCol="0" anchor="ctr"/>
+          <a:lstStyle/>
+          <a:p>
+            <a:pPr indent="0" marL="0">
+              <a:lnSpc>
+                <a:spcPct val="110000"/>
+              </a:lnSpc>
+              <a:buNone/>
+            </a:pPr>
+            <a:r>
+              <a:rPr lang="en-US" sz="1250" dirty="0">
+                <a:solidFill>
+                  <a:srgbClr val="9AA6C0"/>
+                </a:solidFill>
+                <a:latin typeface="Calibri" pitchFamily="34" charset="0"/>
+                <a:ea typeface="Calibri" pitchFamily="34" charset="-122"/>
+                <a:cs typeface="Calibri" pitchFamily="34" charset="-120"/>
+              </a:rPr>
+              <a:t>O grafo (espaços L e P) e todas as métricas do artigo foram calculados com NetworkX:</a:t>
+            </a:r>
+            <a:endParaRPr lang="en-US" sz="1250" dirty="0"/>
+          </a:p>
+        </p:txBody>
+      </p:sp>
+      <p:sp>
+        <p:nvSpPr>
+          <p:cNvPr id="7" name="Text 5"/>
+          <p:cNvSpPr/>
+          <p:nvPr/>
+        </p:nvSpPr>
+        <p:spPr>
+          <a:xfrm>
+            <a:off x="822960" y="2926080"/>
+            <a:ext cx="5074920" cy="2377440"/>
+          </a:xfrm>
+          <a:prstGeom prst="rect">
+            <a:avLst/>
+          </a:prstGeom>
+          <a:noFill/>
+          <a:ln/>
+        </p:spPr>
+        <p:txBody>
+          <a:bodyPr wrap="square" rtlCol="0" anchor="ctr"/>
+          <a:lstStyle/>
+          <a:p>
+            <a:pPr marL="177800" indent="-177800">
+              <a:lnSpc>
+                <a:spcPct val="105000"/>
+              </a:lnSpc>
+              <a:spcAft>
+                <a:spcPts val="700"/>
+              </a:spcAft>
+              <a:buSzPct val="100000"/>
+              <a:buChar char="•"/>
+            </a:pPr>
+            <a:r>
+              <a:rPr lang="en-US" sz="1250" dirty="0">
+                <a:solidFill>
+                  <a:srgbClr val="FFFFFF"/>
+                </a:solidFill>
+                <a:latin typeface="Calibri" pitchFamily="34" charset="0"/>
+                <a:ea typeface="Calibri" pitchFamily="34" charset="-122"/>
+                <a:cs typeface="Calibri" pitchFamily="34" charset="-120"/>
+              </a:rPr>
+              <a:t>betweenness_centrality — Luz e Brás como pontos críticos</a:t>
+            </a:r>
+            <a:endParaRPr lang="en-US" sz="1250" dirty="0"/>
+          </a:p>
+          <a:p>
+            <a:pPr marL="177800" indent="-177800">
+              <a:lnSpc>
+                <a:spcPct val="105000"/>
+              </a:lnSpc>
+              <a:spcAft>
+                <a:spcPts val="700"/>
+              </a:spcAft>
+              <a:buSzPct val="100000"/>
+              <a:buChar char="•"/>
+            </a:pPr>
+            <a:r>
+              <a:rPr lang="en-US" sz="1250" dirty="0">
+                <a:solidFill>
+                  <a:srgbClr val="FFFFFF"/>
+                </a:solidFill>
+                <a:latin typeface="Calibri" pitchFamily="34" charset="0"/>
+                <a:ea typeface="Calibri" pitchFamily="34" charset="-122"/>
+                <a:cs typeface="Calibri" pitchFamily="34" charset="-120"/>
+              </a:rPr>
+              <a:t>global_efficiency · average_shortest_path_length — E_glob e L</a:t>
+            </a:r>
+            <a:endParaRPr lang="en-US" sz="1250" dirty="0"/>
+          </a:p>
+          <a:p>
+            <a:pPr marL="177800" indent="-177800">
+              <a:lnSpc>
+                <a:spcPct val="105000"/>
+              </a:lnSpc>
+              <a:spcAft>
+                <a:spcPts val="700"/>
+              </a:spcAft>
+              <a:buSzPct val="100000"/>
+              <a:buChar char="•"/>
+            </a:pPr>
+            <a:r>
+              <a:rPr lang="en-US" sz="1250" dirty="0">
+                <a:solidFill>
+                  <a:srgbClr val="FFFFFF"/>
+                </a:solidFill>
+                <a:latin typeface="Calibri" pitchFamily="34" charset="0"/>
+                <a:ea typeface="Calibri" pitchFamily="34" charset="-122"/>
+                <a:cs typeface="Calibri" pitchFamily="34" charset="-120"/>
+              </a:rPr>
+              <a:t>community (Louvain) — modularidade Q e as 15 regiões</a:t>
+            </a:r>
+            <a:endParaRPr lang="en-US" sz="1250" dirty="0"/>
+          </a:p>
+          <a:p>
+            <a:pPr marL="177800" indent="-177800">
+              <a:lnSpc>
+                <a:spcPct val="105000"/>
+              </a:lnSpc>
+              <a:spcAft>
+                <a:spcPts val="700"/>
+              </a:spcAft>
+              <a:buSzPct val="100000"/>
+              <a:buChar char="•"/>
+            </a:pPr>
+            <a:r>
+              <a:rPr lang="en-US" sz="1250" dirty="0">
+                <a:solidFill>
+                  <a:srgbClr val="FFFFFF"/>
+                </a:solidFill>
+                <a:latin typeface="Calibri" pitchFamily="34" charset="0"/>
+                <a:ea typeface="Calibri" pitchFamily="34" charset="-122"/>
+                <a:cs typeface="Calibri" pitchFamily="34" charset="-120"/>
+              </a:rPr>
+              <a:t>gnm_random_graph — índice de mundo pequeno σ</a:t>
+            </a:r>
+            <a:endParaRPr lang="en-US" sz="1250" dirty="0"/>
+          </a:p>
+          <a:p>
+            <a:pPr marL="177800" indent="-177800">
+              <a:lnSpc>
+                <a:spcPct val="105000"/>
+              </a:lnSpc>
+              <a:buSzPct val="100000"/>
+              <a:buChar char="•"/>
+            </a:pPr>
+            <a:r>
+              <a:rPr lang="en-US" sz="1250" dirty="0">
+                <a:solidFill>
+                  <a:srgbClr val="FFFFFF"/>
+                </a:solidFill>
+                <a:latin typeface="Calibri" pitchFamily="34" charset="0"/>
+                <a:ea typeface="Calibri" pitchFamily="34" charset="-122"/>
+                <a:cs typeface="Calibri" pitchFamily="34" charset="-120"/>
+              </a:rPr>
+              <a:t>connected_components — robustez sob falha e ataque</a:t>
+            </a:r>
+            <a:endParaRPr lang="en-US" sz="1250" dirty="0"/>
+          </a:p>
+        </p:txBody>
+      </p:sp>
+      <p:sp>
+        <p:nvSpPr>
+          <p:cNvPr id="8" name="Shape 6"/>
+          <p:cNvSpPr/>
+          <p:nvPr/>
+        </p:nvSpPr>
+        <p:spPr>
+          <a:xfrm>
+            <a:off x="6172200" y="1645920"/>
+            <a:ext cx="5486400" cy="3794760"/>
+          </a:xfrm>
+          <a:prstGeom prst="roundRect">
+            <a:avLst>
+              <a:gd name="adj" fmla="val 2892"/>
+            </a:avLst>
+          </a:prstGeom>
+          <a:solidFill>
+            <a:srgbClr val="1B2540"/>
+          </a:solidFill>
+          <a:ln w="12700">
+            <a:solidFill>
+              <a:srgbClr val="2A3550"/>
+            </a:solidFill>
+            <a:prstDash val="solid"/>
+          </a:ln>
+        </p:spPr>
+      </p:sp>
+      <p:sp>
+        <p:nvSpPr>
+          <p:cNvPr id="9" name="Text 7"/>
+          <p:cNvSpPr/>
+          <p:nvPr/>
+        </p:nvSpPr>
+        <p:spPr>
+          <a:xfrm>
+            <a:off x="6400800" y="1828800"/>
+            <a:ext cx="5029200" cy="365760"/>
+          </a:xfrm>
+          <a:prstGeom prst="rect">
+            <a:avLst/>
+          </a:prstGeom>
+          <a:noFill/>
+          <a:ln/>
+        </p:spPr>
+        <p:txBody>
+          <a:bodyPr wrap="square" rtlCol="0" anchor="ctr"/>
+          <a:lstStyle/>
+          <a:p>
+            <a:pPr indent="0" marL="0">
+              <a:buNone/>
+            </a:pPr>
+            <a:r>
+              <a:rPr lang="en-US" sz="1600" b="1" dirty="0">
+                <a:solidFill>
+                  <a:srgbClr val="EB6834"/>
+                </a:solidFill>
+                <a:latin typeface="Calibri" pitchFamily="34" charset="0"/>
+                <a:ea typeface="Calibri" pitchFamily="34" charset="-122"/>
+                <a:cs typeface="Calibri" pitchFamily="34" charset="-120"/>
+              </a:rPr>
+              <a:t>Visualização · Three.js / WebGL</a:t>
+            </a:r>
+            <a:endParaRPr lang="en-US" sz="1600" dirty="0"/>
+          </a:p>
+        </p:txBody>
+      </p:sp>
+      <p:sp>
+        <p:nvSpPr>
+          <p:cNvPr id="10" name="Text 8"/>
+          <p:cNvSpPr/>
+          <p:nvPr/>
+        </p:nvSpPr>
+        <p:spPr>
+          <a:xfrm>
+            <a:off x="6400800" y="2267712"/>
+            <a:ext cx="5029200" cy="548640"/>
+          </a:xfrm>
+          <a:prstGeom prst="rect">
+            <a:avLst/>
+          </a:prstGeom>
+          <a:noFill/>
+          <a:ln/>
+        </p:spPr>
+        <p:txBody>
+          <a:bodyPr wrap="square" rtlCol="0" anchor="ctr"/>
+          <a:lstStyle/>
+          <a:p>
+            <a:pPr indent="0" marL="0">
+              <a:lnSpc>
+                <a:spcPct val="110000"/>
+              </a:lnSpc>
+              <a:buNone/>
+            </a:pPr>
+            <a:r>
+              <a:rPr lang="en-US" sz="1250" dirty="0">
+                <a:solidFill>
+                  <a:srgbClr val="9AA6C0"/>
+                </a:solidFill>
+                <a:latin typeface="Calibri" pitchFamily="34" charset="0"/>
+                <a:ea typeface="Calibri" pitchFamily="34" charset="-122"/>
+                <a:cs typeface="Calibri" pitchFamily="34" charset="-120"/>
+              </a:rPr>
+              <a:t>Artefatos interativos, no navegador, para explorar os resultados:</a:t>
+            </a:r>
+            <a:endParaRPr lang="en-US" sz="1250" dirty="0"/>
+          </a:p>
+        </p:txBody>
+      </p:sp>
+      <p:sp>
+        <p:nvSpPr>
+          <p:cNvPr id="11" name="Text 9"/>
+          <p:cNvSpPr/>
+          <p:nvPr/>
+        </p:nvSpPr>
+        <p:spPr>
+          <a:xfrm>
+            <a:off x="6446520" y="2926080"/>
+            <a:ext cx="5074920" cy="2377440"/>
+          </a:xfrm>
+          <a:prstGeom prst="rect">
+            <a:avLst/>
+          </a:prstGeom>
+          <a:noFill/>
+          <a:ln/>
+        </p:spPr>
+        <p:txBody>
+          <a:bodyPr wrap="square" rtlCol="0" anchor="ctr"/>
+          <a:lstStyle/>
+          <a:p>
+            <a:pPr marL="177800" indent="-177800">
+              <a:lnSpc>
+                <a:spcPct val="105000"/>
+              </a:lnSpc>
+              <a:spcAft>
+                <a:spcPts val="700"/>
+              </a:spcAft>
+              <a:buSzPct val="100000"/>
+              <a:buChar char="•"/>
+            </a:pPr>
+            <a:r>
+              <a:rPr lang="en-US" sz="1250" dirty="0">
+                <a:solidFill>
+                  <a:srgbClr val="FFFFFF"/>
+                </a:solidFill>
+                <a:latin typeface="Calibri" pitchFamily="34" charset="0"/>
+                <a:ea typeface="Calibri" pitchFamily="34" charset="-122"/>
+                <a:cs typeface="Calibri" pitchFamily="34" charset="-120"/>
+              </a:rPr>
+              <a:t>Grafo 3D force-directed da malha, navegável</a:t>
+            </a:r>
+            <a:endParaRPr lang="en-US" sz="1250" dirty="0"/>
+          </a:p>
+          <a:p>
+            <a:pPr marL="177800" indent="-177800">
+              <a:lnSpc>
+                <a:spcPct val="105000"/>
+              </a:lnSpc>
+              <a:spcAft>
+                <a:spcPts val="700"/>
+              </a:spcAft>
+              <a:buSzPct val="100000"/>
+              <a:buChar char="•"/>
+            </a:pPr>
+            <a:r>
+              <a:rPr lang="en-US" sz="1250" dirty="0">
+                <a:solidFill>
+                  <a:srgbClr val="FFFFFF"/>
+                </a:solidFill>
+                <a:latin typeface="Calibri" pitchFamily="34" charset="0"/>
+                <a:ea typeface="Calibri" pitchFamily="34" charset="-122"/>
+                <a:cs typeface="Calibri" pitchFamily="34" charset="-120"/>
+              </a:rPr>
+              <a:t>Explorador: resultados, mapa de calor e planejador de rota</a:t>
+            </a:r>
+            <a:endParaRPr lang="en-US" sz="1250" dirty="0"/>
+          </a:p>
+          <a:p>
+            <a:pPr marL="177800" indent="-177800">
+              <a:lnSpc>
+                <a:spcPct val="105000"/>
+              </a:lnSpc>
+              <a:spcAft>
+                <a:spcPts val="700"/>
+              </a:spcAft>
+              <a:buSzPct val="100000"/>
+              <a:buChar char="•"/>
+            </a:pPr>
+            <a:r>
+              <a:rPr lang="en-US" sz="1250" dirty="0">
+                <a:solidFill>
+                  <a:srgbClr val="FFFFFF"/>
+                </a:solidFill>
+                <a:latin typeface="Calibri" pitchFamily="34" charset="0"/>
+                <a:ea typeface="Calibri" pitchFamily="34" charset="-122"/>
+                <a:cs typeface="Calibri" pitchFamily="34" charset="-120"/>
+              </a:rPr>
+              <a:t>Comparação lado a lado das três malhas</a:t>
+            </a:r>
+            <a:endParaRPr lang="en-US" sz="1250" dirty="0"/>
+          </a:p>
+          <a:p>
+            <a:pPr marL="177800" indent="-177800">
+              <a:lnSpc>
+                <a:spcPct val="105000"/>
+              </a:lnSpc>
+              <a:buSzPct val="100000"/>
+              <a:buChar char="•"/>
+            </a:pPr>
+            <a:r>
+              <a:rPr lang="en-US" sz="1250" dirty="0">
+                <a:solidFill>
+                  <a:srgbClr val="FFFFFF"/>
+                </a:solidFill>
+                <a:latin typeface="Calibri" pitchFamily="34" charset="0"/>
+                <a:ea typeface="Calibri" pitchFamily="34" charset="-122"/>
+                <a:cs typeface="Calibri" pitchFamily="34" charset="-120"/>
+              </a:rPr>
+              <a:t>Globo 3D com São Paulo, Londres e Nova York</a:t>
+            </a:r>
+            <a:endParaRPr lang="en-US" sz="1250" dirty="0"/>
+          </a:p>
+        </p:txBody>
+      </p:sp>
+      <p:sp>
+        <p:nvSpPr>
+          <p:cNvPr id="12" name="Text 10"/>
+          <p:cNvSpPr/>
+          <p:nvPr/>
+        </p:nvSpPr>
+        <p:spPr>
+          <a:xfrm>
+            <a:off x="548640" y="5623560"/>
+            <a:ext cx="11155680" cy="365760"/>
+          </a:xfrm>
+          <a:prstGeom prst="rect">
+            <a:avLst/>
+          </a:prstGeom>
+          <a:noFill/>
+          <a:ln/>
+        </p:spPr>
+        <p:txBody>
+          <a:bodyPr wrap="square" rtlCol="0" anchor="ctr"/>
+          <a:lstStyle/>
+          <a:p>
+            <a:pPr algn="ctr" indent="0" marL="0">
+              <a:buNone/>
+            </a:pPr>
+            <a:r>
+              <a:rPr lang="en-US" sz="1200" i="1" dirty="0">
+                <a:solidFill>
+                  <a:srgbClr val="5E6B8A"/>
+                </a:solidFill>
+                <a:latin typeface="Calibri" pitchFamily="34" charset="0"/>
+                <a:ea typeface="Calibri" pitchFamily="34" charset="-122"/>
+                <a:cs typeface="Calibri" pitchFamily="34" charset="-120"/>
+              </a:rPr>
+              <a:t>NetworkX faz toda a parte quantitativa; Three.js/WebGL, a camada interativa — tudo reprodutível e versionado.</a:t>
+            </a:r>
+            <a:endParaRPr lang="en-US" sz="1200" dirty="0"/>
+          </a:p>
+        </p:txBody>
+      </p:sp>
+      <p:sp>
+        <p:nvSpPr>
+          <p:cNvPr id="14" name="Text 11"/>
+          <p:cNvSpPr/>
+          <p:nvPr/>
+        </p:nvSpPr>
+        <p:spPr>
+          <a:xfrm>
+            <a:off x="11612880" y="6419088"/>
+            <a:ext cx="457200" cy="274320"/>
+          </a:xfrm>
+          <a:prstGeom prst="rect">
+            <a:avLst/>
+          </a:prstGeom>
+          <a:noFill/>
+          <a:ln/>
+        </p:spPr>
+        <p:txBody>
+          <a:bodyPr wrap="square" rtlCol="0" anchor="ctr"/>
+          <a:lstStyle/>
+          <a:p>
+            <a:pPr algn="r" indent="0" marL="0">
+              <a:buNone/>
+            </a:pPr>
+            <a:r>
+              <a:rPr lang="en-US" sz="1000" dirty="0">
+                <a:solidFill>
+                  <a:srgbClr val="5E6B8A"/>
+                </a:solidFill>
+                <a:latin typeface="Calibri" pitchFamily="34" charset="0"/>
+                <a:ea typeface="Calibri" pitchFamily="34" charset="-122"/>
+                <a:cs typeface="Calibri" pitchFamily="34" charset="-120"/>
+              </a:rPr>
+              <a:t>11</a:t>
+            </a:r>
+            <a:endParaRPr lang="en-US" sz="1000" dirty="0"/>
+          </a:p>
+        </p:txBody>
+      </p:sp>
+    </p:spTree>
+  </p:cSld>
+  <p:clrMapOvr>
+    <a:masterClrMapping/>
+  </p:clrMapOvr>
+</p:sld>
+</file>
+
+<file path=ppt/slides/slide12.xml><?xml version="1.0" encoding="utf-8"?>
+<p:sld xmlns:a="http://schemas.openxmlformats.org/drawingml/2006/main" xmlns:r="http://schemas.openxmlformats.org/officeDocument/2006/relationships" xmlns:p="http://schemas.openxmlformats.org/presentationml/2006/main">
+  <p:cSld name="Slide 12">
+    <p:bg>
+      <p:bgPr>
+        <a:solidFill>
+          <a:srgbClr val="0A1024"/>
+        </a:solidFill>
+      </p:bgPr>
+    </p:bg>
+    <p:spTree>
+      <p:nvGrpSpPr>
+        <p:cNvPr id="1" name=""/>
+        <p:cNvGrpSpPr/>
+        <p:nvPr/>
+      </p:nvGrpSpPr>
+      <p:grpSpPr>
+        <a:xfrm>
+          <a:off x="0" y="0"/>
+          <a:ext cx="0" cy="0"/>
+          <a:chOff x="0" y="0"/>
+          <a:chExt cx="0" cy="0"/>
+        </a:xfrm>
+      </p:grpSpPr>
       <p:pic>
         <p:nvPicPr>
           <p:cNvPr id="2" name="Image 0" descr="/tmp/work/slides_img/hero_globe.png">    </p:cNvPr>
@@ -3204,7 +3951,7 @@
                 <a:ea typeface="Calibri" pitchFamily="34" charset="-122"/>
                 <a:cs typeface="Calibri" pitchFamily="34" charset="-120"/>
               </a:rPr>
-              <a:t>11</a:t>
+              <a:t>12</a:t>
             </a:r>
             <a:endParaRPr lang="en-US" sz="1000" dirty="0"/>
           </a:p>

</xml_diff>